<commit_message>
Deploy: push fe3f6ad777588e1d38e6d23af86a0564a81edc55 fe3f6ad777588e1d38e6d23af86a0564a81edc55
</commit_message>
<xml_diff>
--- a/decks/AIYatra-Journey-From-Start-Till-Now.pptx
+++ b/decks/AIYatra-Journey-From-Start-Till-Now.pptx
@@ -7435,7 +7435,7 @@
               </a:defRPr>
             </a:pPr>
             <a:r>
-              <a:t>10 hands-on sessions since Hyderabad — the numbers tell the story of rooms at LSEG, International Tech Park, Madhapur where 2,957 members learn together.</a:t>
+              <a:t>10 hands-on sessions since Hyderabad — the numbers tell the story of rooms where 2,957 members learn together.</a:t>
             </a:r>
           </a:p>
         </p:txBody>
@@ -8497,7 +8497,7 @@
               </a:defRPr>
             </a:pPr>
             <a:r>
-              <a:t>RSVP plus the event Google form at the LSEG gate, then laptops open.</a:t>
+              <a:t>RSVP plus the event Google form at the gate, then laptops open.</a:t>
             </a:r>
           </a:p>
         </p:txBody>
@@ -13054,7 +13054,7 @@
             </a:r>
             <a:br/>
             <a:r>
-              <a:t>Led by super organizer Khaja Moinuddin Mohammed and a crew of passionate volunteers, we meet at LSEG, International Tech Park, Madhapur, Hyderabad.</a:t>
+              <a:t>Led by super organizer Khaja Moinuddin Mohammed and a crew of passionate volunteers, we meet every Saturday in Hyderabad.</a:t>
             </a:r>
           </a:p>
         </p:txBody>
@@ -13301,7 +13301,7 @@
               </a:defRPr>
             </a:pPr>
             <a:r>
-              <a:t>LSEG, International Tech Park, Madhapur, Hyderabad</a:t>
+              <a:t>Hyderabad · venue shared with RSVPs</a:t>
             </a:r>
           </a:p>
         </p:txBody>
@@ -15404,7 +15404,7 @@
               </a:defRPr>
             </a:pPr>
             <a:r>
-              <a:t>LSEG, International Tech Park, Madhapur</a:t>
+              <a:t>Hyderabad · venue shared with RSVPs</a:t>
             </a:r>
             <a:br/>
             <a:r>

</xml_diff>